<commit_message>
docs(presentation): restore the architecture slide (15 slides)
Add «Три модуля связаны форматами, а не вызовами» back, between «Путь
исследователя» and «Гипотеза ≠ Правило». It is the module breakdown restored from
history (commit 487e3e5), with the closing line the brief asked for: «Модули
связаны форматами, а не вызовами. Контракты — JSON Schema; порядок вызовов не
важен.»

- Deck is now 15 slides; renumbered 02–14 (cover and final carry none) and the
  slide ids are sequential again.
- defense_script.md: 5-minute route stays 12 slides (the architecture slide is
  optional and skipped), 10-minute route shows all 15; per-slide speech and both
  time budgets recomputed.
- Rebuilt slide.pdf / slide-light.pdf (15 pages, 2560×1440) and slide.pptx /
  slide-light.pptx (15 slides, timestamps pinned to 1980-01-01).
- Updated the slide lists and page refs in docs/PRESENTATION_VERIFICATION.md,
  docs/AUDIT.md, docs/DEFENSE_CHECKLIST.md, docs/DEMO_CHEATSHEET.md and
  presentation/README.md.
</commit_message>
<xml_diff>
--- a/presentation/slide-light.pptx
+++ b/presentation/slide-light.pptx
@@ -19,6 +19,7 @@
     <p:sldId id="267" r:id="rId18"/>
     <p:sldId id="268" r:id="rId19"/>
     <p:sldId id="269" r:id="rId20"/>
+    <p:sldId id="270" r:id="rId21"/>
   </p:sldIdLst>
   <p:sldSz cx="12191695" cy="6858000" type="screen4x3"/>
   <p:notesSz cx="6858000" cy="9144000"/>
@@ -3302,6 +3303,48 @@
 </file>
 
 <file path=ppt/slides/slide14.xml><?xml version="1.0" encoding="utf-8"?>
+<p:sld xmlns:a="http://schemas.openxmlformats.org/drawingml/2006/main" xmlns:p="http://schemas.openxmlformats.org/presentationml/2006/main" xmlns:r="http://schemas.openxmlformats.org/officeDocument/2006/relationships">
+  <p:cSld>
+    <p:spTree>
+      <p:nvGrpSpPr>
+        <p:cNvPr id="1" name=""/>
+        <p:cNvGrpSpPr/>
+        <p:nvPr/>
+      </p:nvGrpSpPr>
+      <p:grpSpPr/>
+      <p:pic>
+        <p:nvPicPr>
+          <p:cNvPr id="2" name="Picture 1" descr="image.jpg"/>
+          <p:cNvPicPr>
+            <a:picLocks noChangeAspect="1"/>
+          </p:cNvPicPr>
+          <p:nvPr/>
+        </p:nvPicPr>
+        <p:blipFill>
+          <a:blip r:embed="rId2"/>
+          <a:stretch>
+            <a:fillRect/>
+          </a:stretch>
+        </p:blipFill>
+        <p:spPr>
+          <a:xfrm>
+            <a:off x="0" y="0"/>
+            <a:ext cx="12191695" cy="6858000"/>
+          </a:xfrm>
+          <a:prstGeom prst="rect">
+            <a:avLst/>
+          </a:prstGeom>
+        </p:spPr>
+      </p:pic>
+    </p:spTree>
+  </p:cSld>
+  <p:clrMapOvr>
+    <a:masterClrMapping/>
+  </p:clrMapOvr>
+</p:sld>
+</file>
+
+<file path=ppt/slides/slide15.xml><?xml version="1.0" encoding="utf-8"?>
 <p:sld xmlns:a="http://schemas.openxmlformats.org/drawingml/2006/main" xmlns:p="http://schemas.openxmlformats.org/presentationml/2006/main" xmlns:r="http://schemas.openxmlformats.org/officeDocument/2006/relationships">
   <p:cSld>
     <p:spTree>

</xml_diff>